<commit_message>
presentation: remove teal circle badges from agenda slide
</commit_message>
<xml_diff>
--- a/AareML-presentation.pptx
+++ b/AareML-presentation.pptx
@@ -4190,26 +4190,6 @@
       </p:sp>
       <p:sp>
         <p:nvSpPr>
-          <p:cNvPr id="5" name="Shape 3"/>
-          <p:cNvSpPr/>
-          <p:nvPr/>
-        </p:nvSpPr>
-        <p:spPr>
-          <a:xfrm>
-            <a:off x="457200" y="1005840"/>
-            <a:ext cx="347472" cy="347472"/>
-          </a:xfrm>
-          <a:prstGeom prst="ellipse">
-            <a:avLst/>
-          </a:prstGeom>
-          <a:solidFill>
-            <a:srgbClr val="01696F"/>
-          </a:solidFill>
-          <a:ln/>
-        </p:spPr>
-      </p:sp>
-      <p:sp>
-        <p:nvSpPr>
           <p:cNvPr id="6" name="Text 4"/>
           <p:cNvSpPr/>
           <p:nvPr/>
@@ -4288,26 +4268,6 @@
       </p:sp>
       <p:sp>
         <p:nvSpPr>
-          <p:cNvPr id="8" name="Shape 6"/>
-          <p:cNvSpPr/>
-          <p:nvPr/>
-        </p:nvSpPr>
-        <p:spPr>
-          <a:xfrm>
-            <a:off x="457200" y="1600200"/>
-            <a:ext cx="347472" cy="347472"/>
-          </a:xfrm>
-          <a:prstGeom prst="ellipse">
-            <a:avLst/>
-          </a:prstGeom>
-          <a:solidFill>
-            <a:srgbClr val="01696F"/>
-          </a:solidFill>
-          <a:ln/>
-        </p:spPr>
-      </p:sp>
-      <p:sp>
-        <p:nvSpPr>
           <p:cNvPr id="9" name="Text 7"/>
           <p:cNvSpPr/>
           <p:nvPr/>
@@ -4386,26 +4346,6 @@
       </p:sp>
       <p:sp>
         <p:nvSpPr>
-          <p:cNvPr id="11" name="Shape 9"/>
-          <p:cNvSpPr/>
-          <p:nvPr/>
-        </p:nvSpPr>
-        <p:spPr>
-          <a:xfrm>
-            <a:off x="457200" y="2194560"/>
-            <a:ext cx="347472" cy="347472"/>
-          </a:xfrm>
-          <a:prstGeom prst="ellipse">
-            <a:avLst/>
-          </a:prstGeom>
-          <a:solidFill>
-            <a:srgbClr val="01696F"/>
-          </a:solidFill>
-          <a:ln/>
-        </p:spPr>
-      </p:sp>
-      <p:sp>
-        <p:nvSpPr>
           <p:cNvPr id="12" name="Text 10"/>
           <p:cNvSpPr/>
           <p:nvPr/>
@@ -4484,26 +4424,6 @@
       </p:sp>
       <p:sp>
         <p:nvSpPr>
-          <p:cNvPr id="14" name="Shape 12"/>
-          <p:cNvSpPr/>
-          <p:nvPr/>
-        </p:nvSpPr>
-        <p:spPr>
-          <a:xfrm>
-            <a:off x="457200" y="2788920"/>
-            <a:ext cx="347472" cy="347472"/>
-          </a:xfrm>
-          <a:prstGeom prst="ellipse">
-            <a:avLst/>
-          </a:prstGeom>
-          <a:solidFill>
-            <a:srgbClr val="01696F"/>
-          </a:solidFill>
-          <a:ln/>
-        </p:spPr>
-      </p:sp>
-      <p:sp>
-        <p:nvSpPr>
           <p:cNvPr id="15" name="Text 13"/>
           <p:cNvSpPr/>
           <p:nvPr/>
@@ -4582,26 +4502,6 @@
       </p:sp>
       <p:sp>
         <p:nvSpPr>
-          <p:cNvPr id="17" name="Shape 15"/>
-          <p:cNvSpPr/>
-          <p:nvPr/>
-        </p:nvSpPr>
-        <p:spPr>
-          <a:xfrm>
-            <a:off x="457200" y="3383280"/>
-            <a:ext cx="347472" cy="347472"/>
-          </a:xfrm>
-          <a:prstGeom prst="ellipse">
-            <a:avLst/>
-          </a:prstGeom>
-          <a:solidFill>
-            <a:srgbClr val="01696F"/>
-          </a:solidFill>
-          <a:ln/>
-        </p:spPr>
-      </p:sp>
-      <p:sp>
-        <p:nvSpPr>
           <p:cNvPr id="18" name="Text 16"/>
           <p:cNvSpPr/>
           <p:nvPr/>
@@ -4677,26 +4577,6 @@
             <a:endParaRPr lang="en-US" sz="1500" dirty="0"/>
           </a:p>
         </p:txBody>
-      </p:sp>
-      <p:sp>
-        <p:nvSpPr>
-          <p:cNvPr id="20" name="Shape 18"/>
-          <p:cNvSpPr/>
-          <p:nvPr/>
-        </p:nvSpPr>
-        <p:spPr>
-          <a:xfrm>
-            <a:off x="457200" y="3977640"/>
-            <a:ext cx="347472" cy="347472"/>
-          </a:xfrm>
-          <a:prstGeom prst="ellipse">
-            <a:avLst/>
-          </a:prstGeom>
-          <a:solidFill>
-            <a:srgbClr val="01696F"/>
-          </a:solidFill>
-          <a:ln/>
-        </p:spPr>
       </p:sp>
       <p:sp>
         <p:nvSpPr>

</xml_diff>

<commit_message>
slide 5: complete NSE+KGE for all models (AR/Ridge/LSTM)
</commit_message>
<xml_diff>
--- a/AareML-presentation.pptx
+++ b/AareML-presentation.pptx
@@ -6527,7 +6527,7 @@
                           <a:ea typeface="Calibri" pitchFamily="34" charset="-122"/>
                           <a:cs typeface="Calibri" pitchFamily="34" charset="-120"/>
                         </a:rPr>
-                        <a:t>—</a:t>
+                        <a:t>0.904</a:t>
                       </a:r>
                       <a:endParaRPr lang="en-US" sz="1200" dirty="0">
                         <a:latin typeface="Calibri" charset="0"/>
@@ -6733,7 +6733,7 @@
                           <a:ea typeface="Calibri" pitchFamily="34" charset="-122"/>
                           <a:cs typeface="Calibri" pitchFamily="34" charset="-120"/>
                         </a:rPr>
-                        <a:t>—</a:t>
+                        <a:t>0.888</a:t>
                       </a:r>
                       <a:endParaRPr lang="en-US" sz="1200" dirty="0">
                         <a:latin typeface="Calibri" charset="0"/>
@@ -7007,7 +7007,7 @@
                           <a:ea typeface="Calibri" pitchFamily="34" charset="-122"/>
                           <a:cs typeface="Calibri" pitchFamily="34" charset="-120"/>
                         </a:rPr>
-                        <a:t>—</a:t>
+                        <a:t>0.891</a:t>
                       </a:r>
                       <a:endParaRPr lang="en-US" sz="1200" dirty="0">
                         <a:latin typeface="Calibri" charset="0"/>

</xml_diff>